<commit_message>
feat(web,demo): one-line plain conclusion; slide 13 shows real web shell screenshot; rebuild video
</commit_message>
<xml_diff>
--- a/docs/demo/typhoeus-demo.pptx
+++ b/docs/demo/typhoeus-demo.pptx
@@ -1174,7 +1174,7 @@
           <a:lstStyle/>
           <a:p>
             <a:r>
-              <a:t>三种形态：插件、值班台、离线验收包。共同的是一套产物和一套护栏。</a:t>
+              <a:t>右边是值班台真实首屏：三个数字、五个问题按钮，审计信息折叠在最后。三种形态：插件、值班台、离线验收包，共用同一套产物和护栏。</a:t>
             </a:r>
           </a:p>
         </p:txBody>
@@ -6048,8 +6048,8 @@
         </p:nvSpPr>
         <p:spPr>
           <a:xfrm>
-            <a:off x="777240" y="1737360"/>
-            <a:ext cx="2377440" cy="457200"/>
+            <a:off x="777240" y="1691640"/>
+            <a:ext cx="3840480" cy="457200"/>
           </a:xfrm>
           <a:prstGeom prst="rect">
             <a:avLst/>
@@ -6065,7 +6065,7 @@
           <a:p>
             <a:pPr algn="l"/>
             <a:r>
-              <a:rPr sz="2000" b="1">
+              <a:rPr sz="1900" b="1">
                 <a:solidFill>
                   <a:srgbClr val="0B6E8F"/>
                 </a:solidFill>
@@ -6084,8 +6084,8 @@
         </p:nvSpPr>
         <p:spPr>
           <a:xfrm>
-            <a:off x="3291840" y="1783080"/>
-            <a:ext cx="6217920" cy="548640"/>
+            <a:off x="777240" y="2148840"/>
+            <a:ext cx="3931920" cy="731520"/>
           </a:xfrm>
           <a:prstGeom prst="rect">
             <a:avLst/>
@@ -6101,13 +6101,13 @@
           <a:p>
             <a:pPr algn="l"/>
             <a:r>
-              <a:rPr sz="1500" b="0">
-                <a:solidFill>
-                  <a:srgbClr val="14212B"/>
-                </a:solidFill>
-                <a:latin typeface="Microsoft YaHei"/>
-              </a:rPr>
-              <a:t>9 个只读工具，装好即用；护栏在工具层</a:t>
+              <a:rPr sz="1300" b="0">
+                <a:solidFill>
+                  <a:srgbClr val="5B6B78"/>
+                </a:solidFill>
+                <a:latin typeface="Microsoft YaHei"/>
+              </a:rPr>
+              <a:t>9 个只读工具，护栏在工具层</a:t>
             </a:r>
           </a:p>
         </p:txBody>
@@ -6120,8 +6120,8 @@
         </p:nvSpPr>
         <p:spPr>
           <a:xfrm>
-            <a:off x="9692640" y="1783080"/>
-            <a:ext cx="2011680" cy="457200"/>
+            <a:off x="777240" y="3017520"/>
+            <a:ext cx="3840480" cy="457200"/>
           </a:xfrm>
           <a:prstGeom prst="rect">
             <a:avLst/>
@@ -6137,27 +6137,63 @@
           <a:p>
             <a:pPr algn="l"/>
             <a:r>
-              <a:rPr sz="1200" b="0">
+              <a:rPr sz="1900" b="1">
+                <a:solidFill>
+                  <a:srgbClr val="0B6E8F"/>
+                </a:solidFill>
+                <a:latin typeface="Microsoft YaHei"/>
+              </a:rPr>
+              <a:t>本地值班台</a:t>
+            </a:r>
+          </a:p>
+        </p:txBody>
+      </p:sp>
+      <p:sp>
+        <p:nvSpPr>
+          <p:cNvPr id="7" name="TextBox 6"/>
+          <p:cNvSpPr txBox="1"/>
+          <p:nvPr/>
+        </p:nvSpPr>
+        <p:spPr>
+          <a:xfrm>
+            <a:off x="777240" y="3474720"/>
+            <a:ext cx="3931920" cy="731520"/>
+          </a:xfrm>
+          <a:prstGeom prst="rect">
+            <a:avLst/>
+          </a:prstGeom>
+          <a:noFill/>
+          <a:effectLst/>
+        </p:spPr>
+        <p:txBody>
+          <a:bodyPr wrap="square">
+            <a:spAutoFit/>
+          </a:bodyPr>
+          <a:lstStyle/>
+          <a:p>
+            <a:pPr algn="l"/>
+            <a:r>
+              <a:rPr sz="1300" b="0">
                 <a:solidFill>
                   <a:srgbClr val="5B6B78"/>
                 </a:solidFill>
                 <a:latin typeface="Microsoft YaHei"/>
               </a:rPr>
-              <a:t>typhoeus-mcp</a:t>
-            </a:r>
-          </a:p>
-        </p:txBody>
-      </p:sp>
-      <p:sp>
-        <p:nvSpPr>
-          <p:cNvPr id="7" name="TextBox 6"/>
-          <p:cNvSpPr txBox="1"/>
-          <p:nvPr/>
-        </p:nvSpPr>
-        <p:spPr>
-          <a:xfrm>
-            <a:off x="777240" y="3108960"/>
-            <a:ext cx="2377440" cy="457200"/>
+              <a:t>三个数字 + 常见问题按钮 + 八份产物</a:t>
+            </a:r>
+          </a:p>
+        </p:txBody>
+      </p:sp>
+      <p:sp>
+        <p:nvSpPr>
+          <p:cNvPr id="8" name="TextBox 7"/>
+          <p:cNvSpPr txBox="1"/>
+          <p:nvPr/>
+        </p:nvSpPr>
+        <p:spPr>
+          <a:xfrm>
+            <a:off x="777240" y="4343400"/>
+            <a:ext cx="3840480" cy="457200"/>
           </a:xfrm>
           <a:prstGeom prst="rect">
             <a:avLst/>
@@ -6173,27 +6209,27 @@
           <a:p>
             <a:pPr algn="l"/>
             <a:r>
-              <a:rPr sz="2000" b="1">
+              <a:rPr sz="1900" b="1">
                 <a:solidFill>
                   <a:srgbClr val="0B6E8F"/>
                 </a:solidFill>
                 <a:latin typeface="Microsoft YaHei"/>
               </a:rPr>
-              <a:t>本地值班台</a:t>
-            </a:r>
-          </a:p>
-        </p:txBody>
-      </p:sp>
-      <p:sp>
-        <p:nvSpPr>
-          <p:cNvPr id="8" name="TextBox 7"/>
-          <p:cNvSpPr txBox="1"/>
-          <p:nvPr/>
-        </p:nvSpPr>
-        <p:spPr>
-          <a:xfrm>
-            <a:off x="3291840" y="3154679"/>
-            <a:ext cx="6217920" cy="548640"/>
+              <a:t>离线验收包</a:t>
+            </a:r>
+          </a:p>
+        </p:txBody>
+      </p:sp>
+      <p:sp>
+        <p:nvSpPr>
+          <p:cNvPr id="9" name="TextBox 8"/>
+          <p:cNvSpPr txBox="1"/>
+          <p:nvPr/>
+        </p:nvSpPr>
+        <p:spPr>
+          <a:xfrm>
+            <a:off x="777240" y="4800600"/>
+            <a:ext cx="3931920" cy="731520"/>
           </a:xfrm>
           <a:prstGeom prst="rect">
             <a:avLst/>
@@ -6209,27 +6245,96 @@
           <a:p>
             <a:pPr algn="l"/>
             <a:r>
-              <a:rPr sz="1500" b="0">
-                <a:solidFill>
-                  <a:srgbClr val="14212B"/>
-                </a:solidFill>
-                <a:latin typeface="Microsoft YaHei"/>
-              </a:rPr>
-              <a:t>浏览器打开：三个数字 + 常见问题按钮 + 八份产物</a:t>
-            </a:r>
-          </a:p>
-        </p:txBody>
-      </p:sp>
-      <p:sp>
-        <p:nvSpPr>
-          <p:cNvPr id="9" name="TextBox 8"/>
-          <p:cNvSpPr txBox="1"/>
-          <p:nvPr/>
-        </p:nvSpPr>
-        <p:spPr>
-          <a:xfrm>
-            <a:off x="9692640" y="3154679"/>
-            <a:ext cx="2011680" cy="457200"/>
+              <a:rPr sz="1300" b="0">
+                <a:solidFill>
+                  <a:srgbClr val="5B6B78"/>
+                </a:solidFill>
+                <a:latin typeface="Microsoft YaHei"/>
+              </a:rPr>
+              <a:t>源码 + 数据 + 产物 + 一键验收</a:t>
+            </a:r>
+          </a:p>
+        </p:txBody>
+      </p:sp>
+      <p:pic>
+        <p:nvPicPr>
+          <p:cNvPr id="10" name="Picture 9" descr="webapp_crop.png"/>
+          <p:cNvPicPr>
+            <a:picLocks noChangeAspect="1"/>
+          </p:cNvPicPr>
+          <p:nvPr/>
+        </p:nvPicPr>
+        <p:blipFill>
+          <a:blip r:embed="rId2"/>
+          <a:stretch>
+            <a:fillRect/>
+          </a:stretch>
+        </p:blipFill>
+        <p:spPr>
+          <a:xfrm>
+            <a:off x="5394960" y="1645920"/>
+            <a:ext cx="5943600" cy="4148138"/>
+          </a:xfrm>
+          <a:prstGeom prst="rect">
+            <a:avLst/>
+          </a:prstGeom>
+          <a:effectLst/>
+        </p:spPr>
+      </p:pic>
+      <p:sp>
+        <p:nvSpPr>
+          <p:cNvPr id="11" name="Rectangle 10"/>
+          <p:cNvSpPr/>
+          <p:nvPr/>
+        </p:nvSpPr>
+        <p:spPr>
+          <a:xfrm>
+            <a:off x="5394960" y="1645920"/>
+            <a:ext cx="5943600" cy="4148138"/>
+          </a:xfrm>
+          <a:prstGeom prst="rect">
+            <a:avLst/>
+          </a:prstGeom>
+          <a:noFill/>
+          <a:ln>
+            <a:solidFill>
+              <a:srgbClr val="DDE5EA"/>
+            </a:solidFill>
+          </a:ln>
+          <a:effectLst/>
+        </p:spPr>
+        <p:style>
+          <a:lnRef idx="1">
+            <a:schemeClr val="accent1"/>
+          </a:lnRef>
+          <a:fillRef idx="3">
+            <a:schemeClr val="accent1"/>
+          </a:fillRef>
+          <a:effectRef idx="2">
+            <a:schemeClr val="accent1"/>
+          </a:effectRef>
+          <a:fontRef idx="minor">
+            <a:schemeClr val="lt1"/>
+          </a:fontRef>
+        </p:style>
+        <p:txBody>
+          <a:bodyPr rtlCol="0" anchor="ctr"/>
+          <a:lstStyle/>
+          <a:p>
+            <a:pPr algn="ctr"/>
+          </a:p>
+        </p:txBody>
+      </p:sp>
+      <p:sp>
+        <p:nvSpPr>
+          <p:cNvPr id="12" name="TextBox 11"/>
+          <p:cNvSpPr txBox="1"/>
+          <p:nvPr/>
+        </p:nvSpPr>
+        <p:spPr>
+          <a:xfrm>
+            <a:off x="5394960" y="5806440"/>
+            <a:ext cx="5943600" cy="365760"/>
           </a:xfrm>
           <a:prstGeom prst="rect">
             <a:avLst/>
@@ -6245,121 +6350,13 @@
           <a:p>
             <a:pPr algn="l"/>
             <a:r>
-              <a:rPr sz="1200" b="0">
+              <a:rPr sz="1100" b="0">
                 <a:solidFill>
                   <a:srgbClr val="5B6B78"/>
                 </a:solidFill>
                 <a:latin typeface="Microsoft YaHei"/>
               </a:rPr>
-              <a:t>typhoeus-web</a:t>
-            </a:r>
-          </a:p>
-        </p:txBody>
-      </p:sp>
-      <p:sp>
-        <p:nvSpPr>
-          <p:cNvPr id="10" name="TextBox 9"/>
-          <p:cNvSpPr txBox="1"/>
-          <p:nvPr/>
-        </p:nvSpPr>
-        <p:spPr>
-          <a:xfrm>
-            <a:off x="777240" y="4480560"/>
-            <a:ext cx="2377440" cy="457200"/>
-          </a:xfrm>
-          <a:prstGeom prst="rect">
-            <a:avLst/>
-          </a:prstGeom>
-          <a:noFill/>
-          <a:effectLst/>
-        </p:spPr>
-        <p:txBody>
-          <a:bodyPr wrap="square">
-            <a:spAutoFit/>
-          </a:bodyPr>
-          <a:lstStyle/>
-          <a:p>
-            <a:pPr algn="l"/>
-            <a:r>
-              <a:rPr sz="2000" b="1">
-                <a:solidFill>
-                  <a:srgbClr val="0B6E8F"/>
-                </a:solidFill>
-                <a:latin typeface="Microsoft YaHei"/>
-              </a:rPr>
-              <a:t>离线验收包</a:t>
-            </a:r>
-          </a:p>
-        </p:txBody>
-      </p:sp>
-      <p:sp>
-        <p:nvSpPr>
-          <p:cNvPr id="11" name="TextBox 10"/>
-          <p:cNvSpPr txBox="1"/>
-          <p:nvPr/>
-        </p:nvSpPr>
-        <p:spPr>
-          <a:xfrm>
-            <a:off x="3291840" y="4526280"/>
-            <a:ext cx="6217920" cy="548640"/>
-          </a:xfrm>
-          <a:prstGeom prst="rect">
-            <a:avLst/>
-          </a:prstGeom>
-          <a:noFill/>
-          <a:effectLst/>
-        </p:spPr>
-        <p:txBody>
-          <a:bodyPr wrap="square">
-            <a:spAutoFit/>
-          </a:bodyPr>
-          <a:lstStyle/>
-          <a:p>
-            <a:pPr algn="l"/>
-            <a:r>
-              <a:rPr sz="1500" b="0">
-                <a:solidFill>
-                  <a:srgbClr val="14212B"/>
-                </a:solidFill>
-                <a:latin typeface="Microsoft YaHei"/>
-              </a:rPr>
-              <a:t>源码 + 数据 + 产物 + 一键验收脚本</a:t>
-            </a:r>
-          </a:p>
-        </p:txBody>
-      </p:sp>
-      <p:sp>
-        <p:nvSpPr>
-          <p:cNvPr id="12" name="TextBox 11"/>
-          <p:cNvSpPr txBox="1"/>
-          <p:nvPr/>
-        </p:nvSpPr>
-        <p:spPr>
-          <a:xfrm>
-            <a:off x="9692640" y="4526280"/>
-            <a:ext cx="2011680" cy="457200"/>
-          </a:xfrm>
-          <a:prstGeom prst="rect">
-            <a:avLst/>
-          </a:prstGeom>
-          <a:noFill/>
-          <a:effectLst/>
-        </p:spPr>
-        <p:txBody>
-          <a:bodyPr wrap="square">
-            <a:spAutoFit/>
-          </a:bodyPr>
-          <a:lstStyle/>
-          <a:p>
-            <a:pPr algn="l"/>
-            <a:r>
-              <a:rPr sz="1200" b="0">
-                <a:solidFill>
-                  <a:srgbClr val="5B6B78"/>
-                </a:solidFill>
-                <a:latin typeface="Microsoft YaHei"/>
-              </a:rPr>
-              <a:t>verify.ps1</a:t>
+              <a:t>值班台首屏：三个数字、五个问题按钮、审计折叠</a:t>
             </a:r>
           </a:p>
         </p:txBody>

</xml_diff>

<commit_message>
demo: reposition to what-you-can-do-today; drop boundary slide; rewrite copy per plain-language rules
</commit_message>
<xml_diff>
--- a/docs/demo/typhoeus-demo.pptx
+++ b/docs/demo/typhoeus-demo.pptx
@@ -18,7 +18,6 @@
     <p:sldId id="266" r:id="rId18"/>
     <p:sldId id="267" r:id="rId19"/>
     <p:sldId id="268" r:id="rId20"/>
-    <p:sldId id="269" r:id="rId21"/>
   </p:sldIdLst>
   <p:sldSz cx="12191695" cy="6858000" type="screen4x3"/>
   <p:notesSz cx="6858000" cy="9144000"/>
@@ -366,139 +365,6 @@
 </c:chartSpace>
 </file>
 
-<file path=ppt/charts/chart3.xml><?xml version="1.0" encoding="utf-8"?>
-<c:chartSpace xmlns:c="http://schemas.openxmlformats.org/drawingml/2006/chart" xmlns:a="http://schemas.openxmlformats.org/drawingml/2006/main" xmlns:r="http://schemas.openxmlformats.org/officeDocument/2006/relationships">
-  <c:date1904 val="0"/>
-  <c:chart>
-    <c:autoTitleDeleted val="1"/>
-    <c:plotArea>
-      <c:barChart>
-        <c:barDir val="col"/>
-        <c:grouping val="clustered"/>
-        <c:ser>
-          <c:idx val="0"/>
-          <c:order val="0"/>
-          <c:tx>
-            <c:strRef>
-              <c:f>Sheet1!$B$1</c:f>
-              <c:strCache>
-                <c:ptCount val="1"/>
-                <c:pt idx="0">
-                  <c:v>命中率 %</c:v>
-                </c:pt>
-              </c:strCache>
-            </c:strRef>
-          </c:tx>
-          <c:cat>
-            <c:strRef>
-              <c:f>Sheet1!$A$2:$A$6</c:f>
-              <c:strCache>
-                <c:ptCount val="5"/>
-                <c:pt idx="0">
-                  <c:v>默认（填洼）</c:v>
-                </c:pt>
-                <c:pt idx="1">
-                  <c:v>统一下挖</c:v>
-                </c:pt>
-                <c:pt idx="2">
-                  <c:v>按结构类型</c:v>
-                </c:pt>
-                <c:pt idx="3">
-                  <c:v>+ DEM 汇水</c:v>
-                </c:pt>
-                <c:pt idx="4">
-                  <c:v>+ 小区加深</c:v>
-                </c:pt>
-              </c:strCache>
-            </c:strRef>
-          </c:cat>
-          <c:val>
-            <c:numRef>
-              <c:f>Sheet1!$B$2:$B$6</c:f>
-              <c:numCache>
-                <c:formatCode>General</c:formatCode>
-                <c:ptCount val="5"/>
-                <c:pt idx="0">
-                  <c:v>0.0</c:v>
-                </c:pt>
-                <c:pt idx="1">
-                  <c:v>17.6</c:v>
-                </c:pt>
-                <c:pt idx="2">
-                  <c:v>41.2</c:v>
-                </c:pt>
-                <c:pt idx="3">
-                  <c:v>47.1</c:v>
-                </c:pt>
-                <c:pt idx="4">
-                  <c:v>64.7</c:v>
-                </c:pt>
-              </c:numCache>
-            </c:numRef>
-          </c:val>
-        </c:ser>
-        <c:dLbls>
-          <c:showLegendKey val="0"/>
-          <c:showVal val="1"/>
-          <c:showCatName val="0"/>
-          <c:showSerName val="0"/>
-          <c:showPercent val="0"/>
-          <c:showBubbleSize val="0"/>
-          <c:showLeaderLines val="1"/>
-        </c:dLbls>
-        <c:axId val="-2068027336"/>
-        <c:axId val="-2113994440"/>
-      </c:barChart>
-      <c:catAx>
-        <c:axId val="-2068027336"/>
-        <c:scaling>
-          <c:orientation val="minMax"/>
-        </c:scaling>
-        <c:delete val="0"/>
-        <c:axPos val="b"/>
-        <c:majorTickMark val="out"/>
-        <c:minorTickMark val="none"/>
-        <c:tickLblPos val="nextTo"/>
-        <c:crossAx val="-2113994440"/>
-        <c:crosses val="autoZero"/>
-        <c:auto val="1"/>
-        <c:lblAlgn val="ctr"/>
-        <c:lblOffset val="100"/>
-        <c:noMultiLvlLbl val="0"/>
-      </c:catAx>
-      <c:valAx>
-        <c:axId val="-2113994440"/>
-        <c:scaling>
-          <c:max val="80.0"/>
-        </c:scaling>
-        <c:delete val="0"/>
-        <c:axPos val="l"/>
-        <c:majorGridlines/>
-        <c:majorTickMark val="out"/>
-        <c:minorTickMark val="none"/>
-        <c:tickLblPos val="nextTo"/>
-        <c:crossAx val="-2068027336"/>
-        <c:crosses val="autoZero"/>
-      </c:valAx>
-    </c:plotArea>
-    <c:dispBlanksAs val="gap"/>
-  </c:chart>
-  <c:txPr>
-    <a:bodyPr/>
-    <a:lstStyle/>
-    <a:p>
-      <a:pPr>
-        <a:defRPr sz="1800"/>
-      </a:pPr>
-      <a:endParaRPr lang="en-US"/>
-    </a:p>
-  </c:txPr>
-  <c:externalData r:id="rId1">
-    <c:autoUpdate val="0"/>
-  </c:externalData>
-</c:chartSpace>
-</file>
-
 <file path=ppt/notesMasters/notesMaster1.xml><?xml version="1.0" encoding="utf-8"?>
 <p:notesMaster xmlns:a="http://schemas.openxmlformats.org/drawingml/2006/main" xmlns:p="http://schemas.openxmlformats.org/presentationml/2006/main" xmlns:r="http://schemas.openxmlformats.org/officeDocument/2006/relationships">
   <p:cSld>
@@ -1104,7 +970,7 @@
           <a:lstStyle/>
           <a:p>
             <a:r>
-              <a:t>这一页是全场最重要的：默认链路命中率 0%，因为填洼把下穿立交抹平了。实验层做到 64.7%，但增益集中在单点、且是样本内——这两句要一起说。</a:t>
+              <a:t>右边是值班台真实首屏：三个数字、五个问题按钮，审计信息折叠在最后。三种形态：插件、值班台、离线验收包，共用同一套产物和护栏。</a:t>
             </a:r>
           </a:p>
         </p:txBody>
@@ -1130,76 +996,6 @@
 </file>
 
 <file path=ppt/notesSlides/notesSlide13.xml><?xml version="1.0" encoding="utf-8"?>
-<p:notes xmlns:a="http://schemas.openxmlformats.org/drawingml/2006/main" xmlns:p="http://schemas.openxmlformats.org/presentationml/2006/main" xmlns:r="http://schemas.openxmlformats.org/officeDocument/2006/relationships">
-  <p:cSld>
-    <p:spTree>
-      <p:nvGrpSpPr>
-        <p:cNvPr id="1" name=""/>
-        <p:cNvGrpSpPr/>
-        <p:nvPr/>
-      </p:nvGrpSpPr>
-      <p:grpSpPr>
-        <a:xfrm>
-          <a:off x="0" y="0"/>
-          <a:ext cx="0" cy="0"/>
-          <a:chOff x="0" y="0"/>
-          <a:chExt cx="0" cy="0"/>
-        </a:xfrm>
-      </p:grpSpPr>
-      <p:sp>
-        <p:nvSpPr>
-          <p:cNvPr id="2" name="Slide Image Placeholder 1"/>
-          <p:cNvSpPr>
-            <a:spLocks noGrp="1"/>
-          </p:cNvSpPr>
-          <p:nvPr>
-            <p:ph type="sldImg" idx="2"/>
-          </p:nvPr>
-        </p:nvSpPr>
-        <p:spPr/>
-      </p:sp>
-      <p:sp>
-        <p:nvSpPr>
-          <p:cNvPr id="3" name="Notes Placeholder 2"/>
-          <p:cNvSpPr>
-            <a:spLocks noGrp="1"/>
-          </p:cNvSpPr>
-          <p:nvPr>
-            <p:ph type="body" idx="3" sz="quarter"/>
-          </p:nvPr>
-        </p:nvSpPr>
-        <p:spPr/>
-        <p:txBody>
-          <a:bodyPr/>
-          <a:lstStyle/>
-          <a:p>
-            <a:r>
-              <a:t>右边是值班台真实首屏：三个数字、五个问题按钮，审计信息折叠在最后。三种形态：插件、值班台、离线验收包，共用同一套产物和护栏。</a:t>
-            </a:r>
-          </a:p>
-        </p:txBody>
-      </p:sp>
-      <p:sp>
-        <p:nvSpPr>
-          <p:cNvPr id="4" name="Slide Number Placeholder 3"/>
-          <p:cNvSpPr>
-            <a:spLocks noGrp="1"/>
-          </p:cNvSpPr>
-          <p:nvPr>
-            <p:ph type="sldNum" idx="5" sz="quarter"/>
-          </p:nvPr>
-        </p:nvSpPr>
-        <p:spPr/>
-      </p:sp>
-    </p:spTree>
-  </p:cSld>
-  <p:clrMapOvr>
-    <a:masterClrMapping/>
-  </p:clrMapOvr>
-</p:notes>
-</file>
-
-<file path=ppt/notesSlides/notesSlide14.xml><?xml version="1.0" encoding="utf-8"?>
 <p:notes xmlns:a="http://schemas.openxmlformats.org/drawingml/2006/main" xmlns:p="http://schemas.openxmlformats.org/presentationml/2006/main" xmlns:r="http://schemas.openxmlformats.org/officeDocument/2006/relationships">
   <p:cSld>
     <p:spTree>
@@ -4994,7 +4790,7 @@
                 </a:solidFill>
                 <a:latin typeface="Microsoft YaHei"/>
               </a:rPr>
-              <a:t>内核 0.6.1 ｜ 27 条判据 ｜ 9 个只读工具 ｜ 全链约 70 秒 · 纯 CPU</a:t>
+              <a:t>内核 0.6.1 ｜ 全链 70 秒 ｜ 纯 CPU ｜ 9 个只读工具</a:t>
             </a:r>
           </a:p>
         </p:txBody>
@@ -5084,7 +4880,7 @@
                 </a:solidFill>
                 <a:latin typeface="Microsoft YaHei"/>
               </a:rPr>
-              <a:t>次模贪心，72 小时窗口，双基线同时胜过</a:t>
+              <a:t>同样的队伍，按它排多恢复 27.8% 的功能面积</a:t>
             </a:r>
           </a:p>
         </p:txBody>
@@ -5228,7 +5024,7 @@
                 </a:solidFill>
                 <a:latin typeface="Microsoft YaHei"/>
               </a:rPr>
-              <a:t>• 排名对窗口敏感，所以结论必须带口径</a:t>
+              <a:t>• 排名受窗口影响，数字要带窗口</a:t>
             </a:r>
           </a:p>
         </p:txBody>
@@ -5725,8 +5521,8 @@
                 </a:solidFill>
                 <a:latin typeface="Microsoft YaHei"/>
               </a:rPr>
-              <a:t>IN-FA 面雨量是 AMPIL 的 2.25 倍，峰值反而更低——雨摊在更长时间里。
-这决定了：接亚小时雨强，比接更多总量数据更有价值。</a:t>
+              <a:t>IN-FA 面雨量是 AMPIL 的 2.25 倍，峰值更低，因为雨摊在更长时间里。
+下一步接亚小时雨强，比接更多年总量更有用。</a:t>
             </a:r>
           </a:p>
         </p:txBody>
@@ -5780,7 +5576,7 @@
                 </a:solidFill>
                 <a:latin typeface="Microsoft YaHei"/>
               </a:rPr>
-              <a:t>诚实的边界</a:t>
+              <a:t>形态</a:t>
             </a:r>
           </a:p>
         </p:txBody>
@@ -5816,7 +5612,7 @@
                 </a:solidFill>
                 <a:latin typeface="Microsoft YaHei"/>
               </a:rPr>
-              <a:t>填洼预处理如何抹掉下穿立交的积水</a:t>
+              <a:t>三种用法，一套数据</a:t>
             </a:r>
           </a:p>
         </p:txBody>
@@ -5829,8 +5625,8 @@
         </p:nvSpPr>
         <p:spPr>
           <a:xfrm>
-            <a:off x="731520" y="1554480"/>
-            <a:ext cx="10607040" cy="457200"/>
+            <a:off x="777240" y="1691640"/>
+            <a:ext cx="3840480" cy="457200"/>
           </a:xfrm>
           <a:prstGeom prst="rect">
             <a:avLst/>
@@ -5846,35 +5642,53 @@
           <a:p>
             <a:pPr algn="l"/>
             <a:r>
-              <a:rPr sz="1400" b="0">
+              <a:rPr sz="1900" b="1">
+                <a:solidFill>
+                  <a:srgbClr val="0B6E8F"/>
+                </a:solidFill>
+                <a:latin typeface="Microsoft YaHei"/>
+              </a:rPr>
+              <a:t>DSH 插件</a:t>
+            </a:r>
+          </a:p>
+        </p:txBody>
+      </p:sp>
+      <p:sp>
+        <p:nvSpPr>
+          <p:cNvPr id="5" name="TextBox 4"/>
+          <p:cNvSpPr txBox="1"/>
+          <p:nvPr/>
+        </p:nvSpPr>
+        <p:spPr>
+          <a:xfrm>
+            <a:off x="777240" y="2148840"/>
+            <a:ext cx="3931920" cy="731520"/>
+          </a:xfrm>
+          <a:prstGeom prst="rect">
+            <a:avLst/>
+          </a:prstGeom>
+          <a:noFill/>
+          <a:effectLst/>
+        </p:spPr>
+        <p:txBody>
+          <a:bodyPr wrap="square">
+            <a:spAutoFit/>
+          </a:bodyPr>
+          <a:lstStyle/>
+          <a:p>
+            <a:pPr algn="l"/>
+            <a:r>
+              <a:rPr sz="1300" b="0">
                 <a:solidFill>
                   <a:srgbClr val="5B6B78"/>
                 </a:solidFill>
                 <a:latin typeface="Microsoft YaHei"/>
               </a:rPr>
-              <a:t>17 个域内实测点的分级命中率（同积水分级即命中）</a:t>
-            </a:r>
-          </a:p>
-        </p:txBody>
-      </p:sp>
-      <p:graphicFrame>
-        <p:nvGraphicFramePr>
-          <p:cNvPr id="5" name="Chart 4"/>
-          <p:cNvGraphicFramePr>
-            <a:graphicFrameLocks noGrp="1"/>
-          </p:cNvGraphicFramePr>
-          <p:nvPr/>
-        </p:nvGraphicFramePr>
-        <p:xfrm>
-          <a:off x="731520" y="2011680"/>
-          <a:ext cx="6766560" cy="3108960"/>
-        </p:xfrm>
-        <a:graphic>
-          <a:graphicData uri="http://schemas.openxmlformats.org/drawingml/2006/chart">
-            <c:chart xmlns:c="http://schemas.openxmlformats.org/drawingml/2006/chart" r:id="rId2"/>
-          </a:graphicData>
-        </a:graphic>
-      </p:graphicFrame>
+              <a:t>9 个只读工具，护栏在工具层</a:t>
+            </a:r>
+          </a:p>
+        </p:txBody>
+      </p:sp>
       <p:sp>
         <p:nvSpPr>
           <p:cNvPr id="6" name="TextBox 5"/>
@@ -5883,8 +5697,8 @@
         </p:nvSpPr>
         <p:spPr>
           <a:xfrm>
-            <a:off x="7772400" y="2011680"/>
-            <a:ext cx="3840480" cy="3108960"/>
+            <a:off x="777240" y="3017520"/>
+            <a:ext cx="3840480" cy="457200"/>
           </a:xfrm>
           <a:prstGeom prst="rect">
             <a:avLst/>
@@ -5900,16 +5714,13 @@
           <a:p>
             <a:pPr algn="l"/>
             <a:r>
-              <a:rPr sz="1600" b="0">
-                <a:solidFill>
-                  <a:srgbClr val="14212B"/>
-                </a:solidFill>
-                <a:latin typeface="Microsoft YaHei"/>
-              </a:rPr>
-              <a:t>默认链路：0.0%
-实验层：64.7%
-增益集中于单点，
-且属样本内结果。</a:t>
+              <a:rPr sz="1900" b="1">
+                <a:solidFill>
+                  <a:srgbClr val="0B6E8F"/>
+                </a:solidFill>
+                <a:latin typeface="Microsoft YaHei"/>
+              </a:rPr>
+              <a:t>本地值班台</a:t>
             </a:r>
           </a:p>
         </p:txBody>
@@ -5922,8 +5733,8 @@
         </p:nvSpPr>
         <p:spPr>
           <a:xfrm>
-            <a:off x="777240" y="5257800"/>
-            <a:ext cx="10607040" cy="914400"/>
+            <a:off x="777240" y="3474720"/>
+            <a:ext cx="3931920" cy="731520"/>
           </a:xfrm>
           <a:prstGeom prst="rect">
             <a:avLst/>
@@ -5939,13 +5750,226 @@
           <a:p>
             <a:pPr algn="l"/>
             <a:r>
-              <a:rPr sz="1700" b="1">
-                <a:solidFill>
-                  <a:srgbClr val="14212B"/>
-                </a:solidFill>
-                <a:latin typeface="Microsoft YaHei"/>
-              </a:rPr>
-              <a:t>把失败写在前面：填洼抹平了亚像元凹陷，这不是参数问题，是结构问题。</a:t>
+              <a:rPr sz="1300" b="0">
+                <a:solidFill>
+                  <a:srgbClr val="5B6B78"/>
+                </a:solidFill>
+                <a:latin typeface="Microsoft YaHei"/>
+              </a:rPr>
+              <a:t>三个数字 + 常见问题按钮 + 八份产物</a:t>
+            </a:r>
+          </a:p>
+        </p:txBody>
+      </p:sp>
+      <p:sp>
+        <p:nvSpPr>
+          <p:cNvPr id="8" name="TextBox 7"/>
+          <p:cNvSpPr txBox="1"/>
+          <p:nvPr/>
+        </p:nvSpPr>
+        <p:spPr>
+          <a:xfrm>
+            <a:off x="777240" y="4343400"/>
+            <a:ext cx="3840480" cy="457200"/>
+          </a:xfrm>
+          <a:prstGeom prst="rect">
+            <a:avLst/>
+          </a:prstGeom>
+          <a:noFill/>
+          <a:effectLst/>
+        </p:spPr>
+        <p:txBody>
+          <a:bodyPr wrap="square">
+            <a:spAutoFit/>
+          </a:bodyPr>
+          <a:lstStyle/>
+          <a:p>
+            <a:pPr algn="l"/>
+            <a:r>
+              <a:rPr sz="1900" b="1">
+                <a:solidFill>
+                  <a:srgbClr val="0B6E8F"/>
+                </a:solidFill>
+                <a:latin typeface="Microsoft YaHei"/>
+              </a:rPr>
+              <a:t>离线验收包</a:t>
+            </a:r>
+          </a:p>
+        </p:txBody>
+      </p:sp>
+      <p:sp>
+        <p:nvSpPr>
+          <p:cNvPr id="9" name="TextBox 8"/>
+          <p:cNvSpPr txBox="1"/>
+          <p:nvPr/>
+        </p:nvSpPr>
+        <p:spPr>
+          <a:xfrm>
+            <a:off x="777240" y="4800600"/>
+            <a:ext cx="3931920" cy="731520"/>
+          </a:xfrm>
+          <a:prstGeom prst="rect">
+            <a:avLst/>
+          </a:prstGeom>
+          <a:noFill/>
+          <a:effectLst/>
+        </p:spPr>
+        <p:txBody>
+          <a:bodyPr wrap="square">
+            <a:spAutoFit/>
+          </a:bodyPr>
+          <a:lstStyle/>
+          <a:p>
+            <a:pPr algn="l"/>
+            <a:r>
+              <a:rPr sz="1300" b="0">
+                <a:solidFill>
+                  <a:srgbClr val="5B6B78"/>
+                </a:solidFill>
+                <a:latin typeface="Microsoft YaHei"/>
+              </a:rPr>
+              <a:t>源码 + 数据 + 产物 + 一键验收</a:t>
+            </a:r>
+          </a:p>
+        </p:txBody>
+      </p:sp>
+      <p:pic>
+        <p:nvPicPr>
+          <p:cNvPr id="10" name="Picture 9" descr="webapp_crop.png"/>
+          <p:cNvPicPr>
+            <a:picLocks noChangeAspect="1"/>
+          </p:cNvPicPr>
+          <p:nvPr/>
+        </p:nvPicPr>
+        <p:blipFill>
+          <a:blip r:embed="rId2"/>
+          <a:stretch>
+            <a:fillRect/>
+          </a:stretch>
+        </p:blipFill>
+        <p:spPr>
+          <a:xfrm>
+            <a:off x="5394960" y="1645920"/>
+            <a:ext cx="5943600" cy="4148138"/>
+          </a:xfrm>
+          <a:prstGeom prst="rect">
+            <a:avLst/>
+          </a:prstGeom>
+          <a:effectLst/>
+        </p:spPr>
+      </p:pic>
+      <p:sp>
+        <p:nvSpPr>
+          <p:cNvPr id="11" name="Rectangle 10"/>
+          <p:cNvSpPr/>
+          <p:nvPr/>
+        </p:nvSpPr>
+        <p:spPr>
+          <a:xfrm>
+            <a:off x="5394960" y="1645920"/>
+            <a:ext cx="5943600" cy="4148138"/>
+          </a:xfrm>
+          <a:prstGeom prst="rect">
+            <a:avLst/>
+          </a:prstGeom>
+          <a:noFill/>
+          <a:ln>
+            <a:solidFill>
+              <a:srgbClr val="DDE5EA"/>
+            </a:solidFill>
+          </a:ln>
+          <a:effectLst/>
+        </p:spPr>
+        <p:style>
+          <a:lnRef idx="1">
+            <a:schemeClr val="accent1"/>
+          </a:lnRef>
+          <a:fillRef idx="3">
+            <a:schemeClr val="accent1"/>
+          </a:fillRef>
+          <a:effectRef idx="2">
+            <a:schemeClr val="accent1"/>
+          </a:effectRef>
+          <a:fontRef idx="minor">
+            <a:schemeClr val="lt1"/>
+          </a:fontRef>
+        </p:style>
+        <p:txBody>
+          <a:bodyPr rtlCol="0" anchor="ctr"/>
+          <a:lstStyle/>
+          <a:p>
+            <a:pPr algn="ctr"/>
+          </a:p>
+        </p:txBody>
+      </p:sp>
+      <p:sp>
+        <p:nvSpPr>
+          <p:cNvPr id="12" name="TextBox 11"/>
+          <p:cNvSpPr txBox="1"/>
+          <p:nvPr/>
+        </p:nvSpPr>
+        <p:spPr>
+          <a:xfrm>
+            <a:off x="5394960" y="5806440"/>
+            <a:ext cx="5943600" cy="365760"/>
+          </a:xfrm>
+          <a:prstGeom prst="rect">
+            <a:avLst/>
+          </a:prstGeom>
+          <a:noFill/>
+          <a:effectLst/>
+        </p:spPr>
+        <p:txBody>
+          <a:bodyPr wrap="square">
+            <a:spAutoFit/>
+          </a:bodyPr>
+          <a:lstStyle/>
+          <a:p>
+            <a:pPr algn="l"/>
+            <a:r>
+              <a:rPr sz="1100" b="0">
+                <a:solidFill>
+                  <a:srgbClr val="5B6B78"/>
+                </a:solidFill>
+                <a:latin typeface="Microsoft YaHei"/>
+              </a:rPr>
+              <a:t>值班台首屏：三个数字、五个问题按钮、审计折叠</a:t>
+            </a:r>
+          </a:p>
+        </p:txBody>
+      </p:sp>
+      <p:sp>
+        <p:nvSpPr>
+          <p:cNvPr id="13" name="TextBox 12"/>
+          <p:cNvSpPr txBox="1"/>
+          <p:nvPr/>
+        </p:nvSpPr>
+        <p:spPr>
+          <a:xfrm>
+            <a:off x="685800" y="6355080"/>
+            <a:ext cx="10789920" cy="320040"/>
+          </a:xfrm>
+          <a:prstGeom prst="rect">
+            <a:avLst/>
+          </a:prstGeom>
+          <a:noFill/>
+          <a:effectLst/>
+        </p:spPr>
+        <p:txBody>
+          <a:bodyPr wrap="square">
+            <a:spAutoFit/>
+          </a:bodyPr>
+          <a:lstStyle/>
+          <a:p>
+            <a:pPr algn="l"/>
+            <a:r>
+              <a:rPr sz="1000" b="0">
+                <a:solidFill>
+                  <a:srgbClr val="5B6B78"/>
+                </a:solidFill>
+                <a:latin typeface="Microsoft YaHei"/>
+              </a:rPr>
+              <a:t>换机器复算，指纹一致</a:t>
             </a:r>
           </a:p>
         </p:txBody>
@@ -5970,336 +5994,23 @@
       <p:grpSpPr/>
       <p:sp>
         <p:nvSpPr>
-          <p:cNvPr id="2" name="TextBox 1"/>
-          <p:cNvSpPr txBox="1"/>
-          <p:nvPr/>
-        </p:nvSpPr>
-        <p:spPr>
-          <a:xfrm>
-            <a:off x="685800" y="411480"/>
-            <a:ext cx="10789920" cy="365760"/>
-          </a:xfrm>
-          <a:prstGeom prst="rect">
-            <a:avLst/>
-          </a:prstGeom>
-          <a:noFill/>
-          <a:effectLst/>
-        </p:spPr>
-        <p:txBody>
-          <a:bodyPr wrap="square">
-            <a:spAutoFit/>
-          </a:bodyPr>
-          <a:lstStyle/>
-          <a:p>
-            <a:pPr algn="l"/>
-            <a:r>
-              <a:rPr sz="1300" b="1">
-                <a:solidFill>
-                  <a:srgbClr val="0B6E8F"/>
-                </a:solidFill>
-                <a:latin typeface="Microsoft YaHei"/>
-              </a:rPr>
-              <a:t>形态</a:t>
-            </a:r>
-          </a:p>
-        </p:txBody>
-      </p:sp>
-      <p:sp>
-        <p:nvSpPr>
-          <p:cNvPr id="3" name="TextBox 2"/>
-          <p:cNvSpPr txBox="1"/>
-          <p:nvPr/>
-        </p:nvSpPr>
-        <p:spPr>
-          <a:xfrm>
-            <a:off x="685800" y="749808"/>
-            <a:ext cx="10789920" cy="640080"/>
-          </a:xfrm>
-          <a:prstGeom prst="rect">
-            <a:avLst/>
-          </a:prstGeom>
-          <a:noFill/>
-          <a:effectLst/>
-        </p:spPr>
-        <p:txBody>
-          <a:bodyPr wrap="square">
-            <a:spAutoFit/>
-          </a:bodyPr>
-          <a:lstStyle/>
-          <a:p>
-            <a:pPr algn="l"/>
-            <a:r>
-              <a:rPr sz="3000" b="1">
-                <a:solidFill>
-                  <a:srgbClr val="14212B"/>
-                </a:solidFill>
-                <a:latin typeface="Microsoft YaHei"/>
-              </a:rPr>
-              <a:t>三种入口，同一套产物与护栏</a:t>
-            </a:r>
-          </a:p>
-        </p:txBody>
-      </p:sp>
-      <p:sp>
-        <p:nvSpPr>
-          <p:cNvPr id="4" name="TextBox 3"/>
-          <p:cNvSpPr txBox="1"/>
-          <p:nvPr/>
-        </p:nvSpPr>
-        <p:spPr>
-          <a:xfrm>
-            <a:off x="777240" y="1691640"/>
-            <a:ext cx="3840480" cy="457200"/>
-          </a:xfrm>
-          <a:prstGeom prst="rect">
-            <a:avLst/>
-          </a:prstGeom>
-          <a:noFill/>
-          <a:effectLst/>
-        </p:spPr>
-        <p:txBody>
-          <a:bodyPr wrap="square">
-            <a:spAutoFit/>
-          </a:bodyPr>
-          <a:lstStyle/>
-          <a:p>
-            <a:pPr algn="l"/>
-            <a:r>
-              <a:rPr sz="1900" b="1">
-                <a:solidFill>
-                  <a:srgbClr val="0B6E8F"/>
-                </a:solidFill>
-                <a:latin typeface="Microsoft YaHei"/>
-              </a:rPr>
-              <a:t>DSH 插件</a:t>
-            </a:r>
-          </a:p>
-        </p:txBody>
-      </p:sp>
-      <p:sp>
-        <p:nvSpPr>
-          <p:cNvPr id="5" name="TextBox 4"/>
-          <p:cNvSpPr txBox="1"/>
-          <p:nvPr/>
-        </p:nvSpPr>
-        <p:spPr>
-          <a:xfrm>
-            <a:off x="777240" y="2148840"/>
-            <a:ext cx="3931920" cy="731520"/>
-          </a:xfrm>
-          <a:prstGeom prst="rect">
-            <a:avLst/>
-          </a:prstGeom>
-          <a:noFill/>
-          <a:effectLst/>
-        </p:spPr>
-        <p:txBody>
-          <a:bodyPr wrap="square">
-            <a:spAutoFit/>
-          </a:bodyPr>
-          <a:lstStyle/>
-          <a:p>
-            <a:pPr algn="l"/>
-            <a:r>
-              <a:rPr sz="1300" b="0">
-                <a:solidFill>
-                  <a:srgbClr val="5B6B78"/>
-                </a:solidFill>
-                <a:latin typeface="Microsoft YaHei"/>
-              </a:rPr>
-              <a:t>9 个只读工具，护栏在工具层</a:t>
-            </a:r>
-          </a:p>
-        </p:txBody>
-      </p:sp>
-      <p:sp>
-        <p:nvSpPr>
-          <p:cNvPr id="6" name="TextBox 5"/>
-          <p:cNvSpPr txBox="1"/>
-          <p:nvPr/>
-        </p:nvSpPr>
-        <p:spPr>
-          <a:xfrm>
-            <a:off x="777240" y="3017520"/>
-            <a:ext cx="3840480" cy="457200"/>
-          </a:xfrm>
-          <a:prstGeom prst="rect">
-            <a:avLst/>
-          </a:prstGeom>
-          <a:noFill/>
-          <a:effectLst/>
-        </p:spPr>
-        <p:txBody>
-          <a:bodyPr wrap="square">
-            <a:spAutoFit/>
-          </a:bodyPr>
-          <a:lstStyle/>
-          <a:p>
-            <a:pPr algn="l"/>
-            <a:r>
-              <a:rPr sz="1900" b="1">
-                <a:solidFill>
-                  <a:srgbClr val="0B6E8F"/>
-                </a:solidFill>
-                <a:latin typeface="Microsoft YaHei"/>
-              </a:rPr>
-              <a:t>本地值班台</a:t>
-            </a:r>
-          </a:p>
-        </p:txBody>
-      </p:sp>
-      <p:sp>
-        <p:nvSpPr>
-          <p:cNvPr id="7" name="TextBox 6"/>
-          <p:cNvSpPr txBox="1"/>
-          <p:nvPr/>
-        </p:nvSpPr>
-        <p:spPr>
-          <a:xfrm>
-            <a:off x="777240" y="3474720"/>
-            <a:ext cx="3931920" cy="731520"/>
-          </a:xfrm>
-          <a:prstGeom prst="rect">
-            <a:avLst/>
-          </a:prstGeom>
-          <a:noFill/>
-          <a:effectLst/>
-        </p:spPr>
-        <p:txBody>
-          <a:bodyPr wrap="square">
-            <a:spAutoFit/>
-          </a:bodyPr>
-          <a:lstStyle/>
-          <a:p>
-            <a:pPr algn="l"/>
-            <a:r>
-              <a:rPr sz="1300" b="0">
-                <a:solidFill>
-                  <a:srgbClr val="5B6B78"/>
-                </a:solidFill>
-                <a:latin typeface="Microsoft YaHei"/>
-              </a:rPr>
-              <a:t>三个数字 + 常见问题按钮 + 八份产物</a:t>
-            </a:r>
-          </a:p>
-        </p:txBody>
-      </p:sp>
-      <p:sp>
-        <p:nvSpPr>
-          <p:cNvPr id="8" name="TextBox 7"/>
-          <p:cNvSpPr txBox="1"/>
-          <p:nvPr/>
-        </p:nvSpPr>
-        <p:spPr>
-          <a:xfrm>
-            <a:off x="777240" y="4343400"/>
-            <a:ext cx="3840480" cy="457200"/>
-          </a:xfrm>
-          <a:prstGeom prst="rect">
-            <a:avLst/>
-          </a:prstGeom>
-          <a:noFill/>
-          <a:effectLst/>
-        </p:spPr>
-        <p:txBody>
-          <a:bodyPr wrap="square">
-            <a:spAutoFit/>
-          </a:bodyPr>
-          <a:lstStyle/>
-          <a:p>
-            <a:pPr algn="l"/>
-            <a:r>
-              <a:rPr sz="1900" b="1">
-                <a:solidFill>
-                  <a:srgbClr val="0B6E8F"/>
-                </a:solidFill>
-                <a:latin typeface="Microsoft YaHei"/>
-              </a:rPr>
-              <a:t>离线验收包</a:t>
-            </a:r>
-          </a:p>
-        </p:txBody>
-      </p:sp>
-      <p:sp>
-        <p:nvSpPr>
-          <p:cNvPr id="9" name="TextBox 8"/>
-          <p:cNvSpPr txBox="1"/>
-          <p:nvPr/>
-        </p:nvSpPr>
-        <p:spPr>
-          <a:xfrm>
-            <a:off x="777240" y="4800600"/>
-            <a:ext cx="3931920" cy="731520"/>
-          </a:xfrm>
-          <a:prstGeom prst="rect">
-            <a:avLst/>
-          </a:prstGeom>
-          <a:noFill/>
-          <a:effectLst/>
-        </p:spPr>
-        <p:txBody>
-          <a:bodyPr wrap="square">
-            <a:spAutoFit/>
-          </a:bodyPr>
-          <a:lstStyle/>
-          <a:p>
-            <a:pPr algn="l"/>
-            <a:r>
-              <a:rPr sz="1300" b="0">
-                <a:solidFill>
-                  <a:srgbClr val="5B6B78"/>
-                </a:solidFill>
-                <a:latin typeface="Microsoft YaHei"/>
-              </a:rPr>
-              <a:t>源码 + 数据 + 产物 + 一键验收</a:t>
-            </a:r>
-          </a:p>
-        </p:txBody>
-      </p:sp>
-      <p:pic>
-        <p:nvPicPr>
-          <p:cNvPr id="10" name="Picture 9" descr="webapp_crop.png"/>
-          <p:cNvPicPr>
-            <a:picLocks noChangeAspect="1"/>
-          </p:cNvPicPr>
-          <p:nvPr/>
-        </p:nvPicPr>
-        <p:blipFill>
-          <a:blip r:embed="rId2"/>
-          <a:stretch>
-            <a:fillRect/>
-          </a:stretch>
-        </p:blipFill>
-        <p:spPr>
-          <a:xfrm>
-            <a:off x="5394960" y="1645920"/>
-            <a:ext cx="5943600" cy="4148138"/>
-          </a:xfrm>
-          <a:prstGeom prst="rect">
-            <a:avLst/>
-          </a:prstGeom>
-          <a:effectLst/>
-        </p:spPr>
-      </p:pic>
-      <p:sp>
-        <p:nvSpPr>
-          <p:cNvPr id="11" name="Rectangle 10"/>
+          <p:cNvPr id="2" name="Rectangle 1"/>
           <p:cNvSpPr/>
           <p:nvPr/>
         </p:nvSpPr>
         <p:spPr>
           <a:xfrm>
-            <a:off x="5394960" y="1645920"/>
-            <a:ext cx="5943600" cy="4148138"/>
-          </a:xfrm>
-          <a:prstGeom prst="rect">
-            <a:avLst/>
-          </a:prstGeom>
-          <a:noFill/>
+            <a:off x="0" y="0"/>
+            <a:ext cx="12191695" cy="6858000"/>
+          </a:xfrm>
+          <a:prstGeom prst="rect">
+            <a:avLst/>
+          </a:prstGeom>
+          <a:solidFill>
+            <a:srgbClr val="0B3B4A"/>
+          </a:solidFill>
           <a:ln>
-            <a:solidFill>
-              <a:srgbClr val="DDE5EA"/>
-            </a:solidFill>
+            <a:noFill/>
           </a:ln>
           <a:effectLst/>
         </p:spPr>
@@ -6327,140 +6038,6 @@
       </p:sp>
       <p:sp>
         <p:nvSpPr>
-          <p:cNvPr id="12" name="TextBox 11"/>
-          <p:cNvSpPr txBox="1"/>
-          <p:nvPr/>
-        </p:nvSpPr>
-        <p:spPr>
-          <a:xfrm>
-            <a:off x="5394960" y="5806440"/>
-            <a:ext cx="5943600" cy="365760"/>
-          </a:xfrm>
-          <a:prstGeom prst="rect">
-            <a:avLst/>
-          </a:prstGeom>
-          <a:noFill/>
-          <a:effectLst/>
-        </p:spPr>
-        <p:txBody>
-          <a:bodyPr wrap="square">
-            <a:spAutoFit/>
-          </a:bodyPr>
-          <a:lstStyle/>
-          <a:p>
-            <a:pPr algn="l"/>
-            <a:r>
-              <a:rPr sz="1100" b="0">
-                <a:solidFill>
-                  <a:srgbClr val="5B6B78"/>
-                </a:solidFill>
-                <a:latin typeface="Microsoft YaHei"/>
-              </a:rPr>
-              <a:t>值班台首屏：三个数字、五个问题按钮、审计折叠</a:t>
-            </a:r>
-          </a:p>
-        </p:txBody>
-      </p:sp>
-      <p:sp>
-        <p:nvSpPr>
-          <p:cNvPr id="13" name="TextBox 12"/>
-          <p:cNvSpPr txBox="1"/>
-          <p:nvPr/>
-        </p:nvSpPr>
-        <p:spPr>
-          <a:xfrm>
-            <a:off x="685800" y="6355080"/>
-            <a:ext cx="10789920" cy="320040"/>
-          </a:xfrm>
-          <a:prstGeom prst="rect">
-            <a:avLst/>
-          </a:prstGeom>
-          <a:noFill/>
-          <a:effectLst/>
-        </p:spPr>
-        <p:txBody>
-          <a:bodyPr wrap="square">
-            <a:spAutoFit/>
-          </a:bodyPr>
-          <a:lstStyle/>
-          <a:p>
-            <a:pPr algn="l"/>
-            <a:r>
-              <a:rPr sz="1000" b="0">
-                <a:solidFill>
-                  <a:srgbClr val="5B6B78"/>
-                </a:solidFill>
-                <a:latin typeface="Microsoft YaHei"/>
-              </a:rPr>
-              <a:t>27 条判据：15 通过 / 5 不达标 / 7 缺外部数据；换机器复算指纹一致</a:t>
-            </a:r>
-          </a:p>
-        </p:txBody>
-      </p:sp>
-    </p:spTree>
-  </p:cSld>
-  <p:clrMapOvr>
-    <a:masterClrMapping/>
-  </p:clrMapOvr>
-</p:sld>
-</file>
-
-<file path=ppt/slides/slide14.xml><?xml version="1.0" encoding="utf-8"?>
-<p:sld xmlns:a="http://schemas.openxmlformats.org/drawingml/2006/main" xmlns:p="http://schemas.openxmlformats.org/presentationml/2006/main" xmlns:r="http://schemas.openxmlformats.org/officeDocument/2006/relationships">
-  <p:cSld>
-    <p:spTree>
-      <p:nvGrpSpPr>
-        <p:cNvPr id="1" name=""/>
-        <p:cNvGrpSpPr/>
-        <p:nvPr/>
-      </p:nvGrpSpPr>
-      <p:grpSpPr/>
-      <p:sp>
-        <p:nvSpPr>
-          <p:cNvPr id="2" name="Rectangle 1"/>
-          <p:cNvSpPr/>
-          <p:nvPr/>
-        </p:nvSpPr>
-        <p:spPr>
-          <a:xfrm>
-            <a:off x="0" y="0"/>
-            <a:ext cx="12191695" cy="6858000"/>
-          </a:xfrm>
-          <a:prstGeom prst="rect">
-            <a:avLst/>
-          </a:prstGeom>
-          <a:solidFill>
-            <a:srgbClr val="0B3B4A"/>
-          </a:solidFill>
-          <a:ln>
-            <a:noFill/>
-          </a:ln>
-          <a:effectLst/>
-        </p:spPr>
-        <p:style>
-          <a:lnRef idx="1">
-            <a:schemeClr val="accent1"/>
-          </a:lnRef>
-          <a:fillRef idx="3">
-            <a:schemeClr val="accent1"/>
-          </a:fillRef>
-          <a:effectRef idx="2">
-            <a:schemeClr val="accent1"/>
-          </a:effectRef>
-          <a:fontRef idx="minor">
-            <a:schemeClr val="lt1"/>
-          </a:fontRef>
-        </p:style>
-        <p:txBody>
-          <a:bodyPr rtlCol="0" anchor="ctr"/>
-          <a:lstStyle/>
-          <a:p>
-            <a:pPr algn="ctr"/>
-          </a:p>
-        </p:txBody>
-      </p:sp>
-      <p:sp>
-        <p:nvSpPr>
           <p:cNvPr id="3" name="TextBox 2"/>
           <p:cNvSpPr txBox="1"/>
           <p:nvPr/>
@@ -6520,15 +6097,15 @@
           <a:p>
             <a:pPr algn="l"/>
             <a:r>
-              <a:rPr sz="3000" b="1">
+              <a:rPr sz="3400" b="1">
                 <a:solidFill>
                   <a:srgbClr val="FFFFFF"/>
                 </a:solidFill>
                 <a:latin typeface="Microsoft YaHei"/>
               </a:rPr>
-              <a:t>它面对的是台风暴雨下的复合气候风险；
-智能模型要做的，是在资料不全时
-快速完成分级、核算与排序。</a:t>
+              <a:t>今天就能用：排出 12 个点、
+定下 258 毫米的启动线、
+排好抢修顺序。</a:t>
             </a:r>
           </a:p>
         </p:txBody>
@@ -6564,7 +6141,7 @@
                 </a:solidFill>
                 <a:latin typeface="Microsoft YaHei"/>
               </a:rPr>
-              <a:t>18 场 · 36 年 ｜ 27 条判据 ｜ 9 个只读工具 ｜ 全链约 70 秒</a:t>
+              <a:t>18 场台风 / 36 年 / 全链 70 秒 / 9 个只读工具</a:t>
             </a:r>
           </a:p>
         </p:txBody>
@@ -6690,7 +6267,7 @@
                 </a:solidFill>
                 <a:latin typeface="Microsoft YaHei"/>
               </a:rPr>
-              <a:t>评估周期与决策窗口，差了两个数量级</a:t>
+              <a:t>台风过后，三个问题必须当天回答</a:t>
             </a:r>
           </a:p>
         </p:txBody>
@@ -6772,7 +6349,7 @@
                 </a:solidFill>
                 <a:latin typeface="Microsoft YaHei"/>
               </a:rPr>
-              <a:t>3–6 个月</a:t>
+              <a:t>布在哪</a:t>
             </a:r>
           </a:p>
         </p:txBody>
@@ -6808,7 +6385,7 @@
                 </a:solidFill>
                 <a:latin typeface="Microsoft YaHei"/>
               </a:rPr>
-              <a:t>传统水力模型单片区：资料整编 → 率定 → 出图 → 评审</a:t>
+              <a:t>12 个点先布还是后布，靠人手抄台账对不上时间</a:t>
             </a:r>
           </a:p>
         </p:txBody>
@@ -6890,7 +6467,7 @@
                 </a:solidFill>
                 <a:latin typeface="Microsoft YaHei"/>
               </a:rPr>
-              <a:t>数小时</a:t>
+              <a:t>什么时候启动</a:t>
             </a:r>
           </a:p>
         </p:txBody>
@@ -6926,7 +6503,7 @@
                 </a:solidFill>
                 <a:latin typeface="Microsoft YaHei"/>
               </a:rPr>
-              <a:t>台风自登陆到积水峰值：布点、封道、泵车必须在这段时间内定</a:t>
+              <a:t>雨量到多少毫米、风到多少级，预案里没有本片区的数字</a:t>
             </a:r>
           </a:p>
         </p:txBody>
@@ -7008,7 +6585,7 @@
                 </a:solidFill>
                 <a:latin typeface="Microsoft YaHei"/>
               </a:rPr>
-              <a:t>0 套</a:t>
+              <a:t>花多少钱</a:t>
             </a:r>
           </a:p>
         </p:txBody>
@@ -7044,7 +6621,7 @@
                 </a:solidFill>
                 <a:latin typeface="Microsoft YaHei"/>
               </a:rPr>
-              <a:t>可被第三方逐位复算的交付物——图纸与报告对不上参数</a:t>
+              <a:t>换 1% 的损失要投多少，立项时给不出区间</a:t>
             </a:r>
           </a:p>
         </p:txBody>
@@ -7080,7 +6657,7 @@
                 </a:solidFill>
                 <a:latin typeface="Microsoft YaHei"/>
               </a:rPr>
-              <a:t>结果：雨已经在下了，结论还没成型；等结论出来，抢修的最佳次序已经过去。</a:t>
+              <a:t>三个问题以前要等评估报告；报告出来，雨已经过去了。</a:t>
             </a:r>
           </a:p>
         </p:txBody>
@@ -7206,7 +6783,7 @@
                 </a:solidFill>
                 <a:latin typeface="Microsoft YaHei"/>
               </a:rPr>
-              <a:t>一条可复算的决策链，四步走完</a:t>
+              <a:t>四步，把一场雨变成三张能用的单子</a:t>
             </a:r>
           </a:p>
         </p:txBody>
@@ -7432,7 +7009,7 @@
                 </a:solidFill>
                 <a:latin typeface="Microsoft YaHei"/>
               </a:rPr>
-              <a:t>一次推演编译八份结构化产物，跨产物逐对校验</a:t>
+              <a:t>八份产物：布点单、抢修单、价目表、对账单等</a:t>
             </a:r>
           </a:p>
         </p:txBody>
@@ -7658,7 +7235,7 @@
                 </a:solidFill>
                 <a:latin typeface="Microsoft YaHei"/>
               </a:rPr>
-              <a:t>按岗位重组为涝点卡、决策卡、避险页三类产品</a:t>
+              <a:t>值班员拿布点单，规划岗拿价目表，公众拿避险页</a:t>
             </a:r>
           </a:p>
         </p:txBody>
@@ -7694,7 +7271,7 @@
                 </a:solidFill>
                 <a:latin typeface="Microsoft YaHei"/>
               </a:rPr>
-              <a:t>每个数字都带两枚指纹：配置 config_hash、数据 source_hash</a:t>
+              <a:t>全链 70 秒；每个数字带配置与数据指纹，可复算</a:t>
             </a:r>
           </a:p>
         </p:txBody>
@@ -7784,7 +7361,7 @@
                 </a:solidFill>
                 <a:latin typeface="Microsoft YaHei"/>
               </a:rPr>
-              <a:t>四层结构，层间只通过落盘产物通信</a:t>
+              <a:t>四层结构，层与层之间只通过已保存的文件通信</a:t>
             </a:r>
           </a:p>
         </p:txBody>
@@ -8204,7 +7781,7 @@
                 </a:solidFill>
                 <a:latin typeface="Microsoft YaHei"/>
               </a:rPr>
-              <a:t>9 个只读工具 + 4 条护栏：越域拒答、弱基线不出排序、单口径不返数字</a:t>
+              <a:t>9 个只读工具 + 4 条限制：越域拒答、弱基线不出排序、单口径不返数字</a:t>
             </a:r>
           </a:p>
         </p:txBody>
@@ -8428,7 +8005,7 @@
                 </a:solidFill>
                 <a:latin typeface="Microsoft YaHei"/>
               </a:rPr>
-              <a:t>服务层只能读已落盘、带指纹的产物；不重算内核、不改参数、不写文件</a:t>
+              <a:t>服务层只读已保存的文件，不重算、不改参数、不写文件</a:t>
             </a:r>
           </a:p>
         </p:txBody>
@@ -8518,7 +8095,7 @@
                 </a:solidFill>
                 <a:latin typeface="Microsoft YaHei"/>
               </a:rPr>
-              <a:t>六段链路，每一段都能单独回答“为什么”</a:t>
+              <a:t>六步计算，每一步都能单独查</a:t>
             </a:r>
           </a:p>
         </p:txBody>
@@ -9678,7 +9255,7 @@
                 </a:solidFill>
                 <a:latin typeface="Microsoft YaHei"/>
               </a:rPr>
-              <a:t>换一台机器、换一个人，同一份配置与数据能跑出同一组数——这是它能进验收的前提。</a:t>
+              <a:t>换一台机器、换一个人，同一份配置与数据跑出同一组数。</a:t>
             </a:r>
           </a:p>
         </p:txBody>
@@ -10946,7 +10523,7 @@
                 </a:solidFill>
                 <a:latin typeface="Microsoft YaHei"/>
               </a:rPr>
-              <a:t>42.7 h</a:t>
+              <a:t>12 处</a:t>
             </a:r>
           </a:p>
         </p:txBody>
@@ -10982,7 +10559,7 @@
                 </a:solidFill>
                 <a:latin typeface="Microsoft YaHei"/>
               </a:rPr>
-              <a:t>峰值时刻</a:t>
+              <a:t>建议提前布点</a:t>
             </a:r>
           </a:p>
         </p:txBody>
@@ -11018,7 +10595,7 @@
                 </a:solidFill>
                 <a:latin typeface="Microsoft YaHei"/>
               </a:rPr>
-              <a:t>84.2%</a:t>
+              <a:t>258 mm</a:t>
             </a:r>
           </a:p>
         </p:txBody>
@@ -11054,7 +10631,7 @@
                 </a:solidFill>
                 <a:latin typeface="Microsoft YaHei"/>
               </a:rPr>
-              <a:t>绿色格点占比</a:t>
+              <a:t>启动三级响应的雨量</a:t>
             </a:r>
           </a:p>
         </p:txBody>
@@ -11108,9 +10685,9 @@
                 </a:solidFill>
                 <a:latin typeface="Microsoft YaHei"/>
               </a:rPr>
-              <a:t>最大积水出现在下穿立交与低洼路段；
-绿色占八成说明大部分格点不积水，
-风险集中在少数点位——这正是涝点卡要逐点给的原因。</a:t>
+              <a:t>12 处点位、触发雨量 258 毫米、三级响应，
+这些可以直接写进值班表。
+左图是积水分级：八成格点不积水。</a:t>
             </a:r>
           </a:p>
         </p:txBody>
@@ -11236,7 +10813,7 @@
                 </a:solidFill>
                 <a:latin typeface="Microsoft YaHei"/>
               </a:rPr>
-              <a:t>18 场台风、36 年，强度—损失关系稳定</a:t>
+              <a:t>18 场台风、36 年，雨量和损失的关系稳定</a:t>
             </a:r>
           </a:p>
         </p:txBody>
@@ -11519,7 +11096,7 @@
                 </a:solidFill>
                 <a:latin typeface="Microsoft YaHei"/>
               </a:rPr>
-              <a:t>单场叙事会误导适用范围：烟花只是 18 场里的第 2 大。</a:t>
+              <a:t>烟花在 18 场里排第 2。</a:t>
             </a:r>
           </a:p>
         </p:txBody>

</xml_diff>

<commit_message>
adopt expanded domain + sink default: new hashes (3bccaa58/2f3ce75b), peak 0.908m, cards 18/8/2; refresh tests, deck, video, README
</commit_message>
<xml_diff>
--- a/docs/demo/typhoeus-demo.pptx
+++ b/docs/demo/typhoeus-demo.pptx
@@ -10950,7 +10950,7 @@
                 <a:ea typeface="Arial"/>
                 <a:cs typeface="Arial"/>
               </a:rPr>
-              <a:t>守恒相对残差 5.56×10⁻⁹，容差 1×10⁻⁶</a:t>
+              <a:t>守恒相对残差 4.14×10⁻9，容差 1×10⁻⁶</a:t>
             </a:r>
           </a:p>
         </p:txBody>
@@ -11220,7 +11220,7 @@
                 <a:ea typeface="Arial"/>
                 <a:cs typeface="Arial"/>
               </a:rPr>
-              <a:t>e464fea5962b</a:t>
+              <a:t>3bccaa583d77</a:t>
             </a:r>
           </a:p>
         </p:txBody>
@@ -11302,7 +11302,7 @@
                 <a:ea typeface="Arial"/>
                 <a:cs typeface="Arial"/>
               </a:rPr>
-              <a:t>40d07eb29407b4b6</a:t>
+              <a:t>2f3ce75b9462f4f0</a:t>
             </a:r>
           </a:p>
         </p:txBody>
@@ -11487,7 +11487,7 @@
                 <a:ea typeface="Arial"/>
                 <a:cs typeface="Arial"/>
               </a:rPr>
-              <a:t>259.1</a:t>
+              <a:t>250.1</a:t>
             </a:r>
           </a:p>
         </p:txBody>
@@ -11924,7 +11924,7 @@
                 <a:ea typeface="Arial"/>
                 <a:cs typeface="Arial"/>
               </a:rPr>
-              <a:t>残差 5.56×10⁻⁹，超容差停算</a:t>
+              <a:t>残差 4.14×10⁻9，超容差停算</a:t>
             </a:r>
           </a:p>
         </p:txBody>
@@ -13179,7 +13179,7 @@
                 <a:ea typeface="Arial"/>
                 <a:cs typeface="Arial"/>
               </a:rPr>
-              <a:t>259.1</a:t>
+              <a:t>250.1</a:t>
             </a:r>
           </a:p>
         </p:txBody>
@@ -13261,7 +13261,7 @@
                 <a:ea typeface="Arial"/>
                 <a:cs typeface="Arial"/>
               </a:rPr>
-              <a:t>0.493</a:t>
+              <a:t>0.908</a:t>
             </a:r>
           </a:p>
         </p:txBody>
@@ -13562,7 +13562,7 @@
         <p:spPr>
           <a:xfrm>
             <a:off x="2468880" y="3931920"/>
-            <a:ext cx="4157593" cy="274320"/>
+            <a:ext cx="4142780" cy="274320"/>
           </a:xfrm>
           <a:prstGeom prst="rect">
             <a:avLst/>
@@ -13633,7 +13633,7 @@
                 <a:ea typeface="Arial"/>
                 <a:cs typeface="Arial"/>
               </a:rPr>
-              <a:t>84.2%</a:t>
+              <a:t>83.9%</a:t>
             </a:r>
           </a:p>
         </p:txBody>
@@ -13688,7 +13688,7 @@
         <p:spPr>
           <a:xfrm>
             <a:off x="2468880" y="4498848"/>
-            <a:ext cx="641908" cy="274320"/>
+            <a:ext cx="661659" cy="274320"/>
           </a:xfrm>
           <a:prstGeom prst="rect">
             <a:avLst/>
@@ -13759,7 +13759,7 @@
                 <a:ea typeface="Arial"/>
                 <a:cs typeface="Arial"/>
               </a:rPr>
-              <a:t>13.0%</a:t>
+              <a:t>13.4%</a:t>
             </a:r>
           </a:p>
         </p:txBody>

</xml_diff>